<commit_message>
Replace "Interest" with "Earnings" in all user-facing text
Per guideline, the word Interest is no longer used anywhere a user sees
it: labels, headings, error messages, email templates, Excel exports,
the README, the features file and its layout sketches, and the seminar
deck (rebuilt pptx/pdf). "Interest Only" / "Interest and Principal"
become "Earnings Only" / "Earnings and Principal"; "Interest rates"
becomes "Earnings rates"; "Total interest" becomes "Total earnings"; and
so on throughout.

The payout calculation engine in src/lib/payout.ts keeps its internal
names (payoutType values "interest-only"/"interest-and-principal", the
interestCents field, code comments) unchanged, since those are
implementation detail, not UI text. The stored data format, the admin
settings path "config/interest-rates.json", and the "rates.manage"
permission are also unchanged, so no data migration is needed.

Co-Authored-By: Claude Sonnet 5 <noreply@anthropic.com>
</commit_message>
<xml_diff>
--- a/docs/Investment-Plans-Seminar.pptx
+++ b/docs/Investment-Plans-Seminar.pptx
@@ -112,20 +112,20 @@
   <p:extLst>
     <p:ext uri="{521415D9-36F7-43E2-AB2F-B90AF26B5E84}">
       <p14:sectionLst xmlns:p14="http://schemas.microsoft.com/office/powerpoint/2010/main">
-        <p14:section name="Introduction" id="{2739a84d-aed3-54be-f4a3-5c40d84ec705}">
+        <p14:section name="Introduction" id="{b59e9800-49cd-9d60-c6c8-86a1924f90fc}">
           <p14:sldIdLst>
             <p14:sldId id="256"/>
             <p14:sldId id="257"/>
           </p14:sldIdLst>
         </p14:section>
-        <p14:section name="Plans" id="{302225b7-2753-738f-43c6-b2e18cfc656a}">
+        <p14:section name="Plans" id="{aa02689b-d4d5-ff3a-0c44-5c6b193b262e}">
           <p14:sldIdLst>
             <p14:sldId id="258"/>
             <p14:sldId id="259"/>
             <p14:sldId id="260"/>
           </p14:sldIdLst>
         </p14:section>
-        <p14:section name="Next steps" id="{f18bbabe-5740-3ef6-65a8-7b0752c07123}">
+        <p14:section name="Next steps" id="{2ee6af4b-0936-a59e-035a-18981716c395}">
           <p14:sldIdLst>
             <p14:sldId id="261"/>
           </p14:sldIdLst>
@@ -622,7 +622,7 @@
           <a:p>
             <a:r>
               <a:rPr lang="en-US" dirty="0"/>
-              <a:t>Four steps. Pick an amount, lock it in for one or two years, choose how often you are paid, and receive interest each period with your full amount back at the end. The next three slides show what each payout term means in real dollars. Mention the Interest and Principal option for people who want part of their money back sooner.</a:t>
+              <a:t>Four steps. Pick an amount, lock it in for one or two years, choose how often you are paid, and receive earnings each period with your full amount back at the end. The next three slides show what each payout term means in real dollars. Mention the Earnings and Principal option for people who want part of their money back sooner.</a:t>
             </a:r>
             <a:endParaRPr lang="en-US" dirty="0"/>
           </a:p>
@@ -710,7 +710,7 @@
           <a:p>
             <a:r>
               <a:rPr lang="en-US" dirty="0"/>
-              <a:t>Quarterly payouts. You are paid every 3 months. On $25,000 that is $500 each time. Over a 1-year term that is 4 payouts; over 2 years, 8 payouts. Your full investment is returned with the last payout. The table shows total interest and the total you receive for $25,000, $50,000 and $100,000.</a:t>
+              <a:t>Quarterly payouts. You are paid every 3 months. On $25,000 that is $500 each time. Over a 1-year term that is 4 payouts; over 2 years, 8 payouts. Your full investment is returned with the last payout. The table shows total earnings and the total you receive for $25,000, $50,000 and $100,000.</a:t>
             </a:r>
             <a:endParaRPr lang="en-US" dirty="0"/>
           </a:p>
@@ -798,7 +798,7 @@
           <a:p>
             <a:r>
               <a:rPr lang="en-US" dirty="0"/>
-              <a:t>Half-yearly payouts. You are paid every 6 months. On $25,000 that is $1,125 each time. Over a 1-year term that is 2 payouts; over 2 years, 4 payouts. Your full investment is returned with the last payout. The table shows total interest and the total you receive for $25,000, $50,000 and $100,000.</a:t>
+              <a:t>Half-yearly payouts. You are paid every 6 months. On $25,000 that is $1,125 each time. Over a 1-year term that is 2 payouts; over 2 years, 4 payouts. Your full investment is returned with the last payout. The table shows total earnings and the total you receive for $25,000, $50,000 and $100,000.</a:t>
             </a:r>
             <a:endParaRPr lang="en-US" dirty="0"/>
           </a:p>
@@ -886,7 +886,7 @@
           <a:p>
             <a:r>
               <a:rPr lang="en-US" dirty="0"/>
-              <a:t>Yearly payouts. You are paid once a year. On $25,000 that is $2,500 each time. Over a 1-year term that is 1 payout; over 2 years, 2 payouts. Your full investment is returned with the last payout. The table shows total interest and the total you receive for $25,000, $50,000 and $100,000.</a:t>
+              <a:t>Yearly payouts. You are paid once a year. On $25,000 that is $2,500 each time. Over a 1-year term that is 1 payout; over 2 years, 2 payouts. Your full investment is returned with the last payout. The table shows total earnings and the total you receive for $25,000, $50,000 and $100,000.</a:t>
             </a:r>
             <a:endParaRPr lang="en-US" dirty="0"/>
           </a:p>
@@ -2880,7 +2880,7 @@
                   <a:schemeClr val="tx1"/>
                 </a:solidFill>
               </a:rPr>
-              <a:t>Interest every period, your full amount back at the end</a:t>
+              <a:t>Earnings every period, your full amount back at the end</a:t>
             </a:r>
             <a:endParaRPr lang="en-US" sz="1600" dirty="0"/>
           </a:p>
@@ -2954,7 +2954,7 @@
                   <a:schemeClr val="tx1"/>
                 </a:solidFill>
               </a:rPr>
-              <a:t>Interest is simple (not compounded) and starts the next business day after you invest. Prefer part of your money back with every payout? Choose </a:t>
+              <a:t>Earnings are simple (not compounded) and start the next business day after you invest. Prefer part of your money back with every payout? Choose </a:t>
             </a:r>
             <a:pPr indent="0" marL="0">
               <a:buNone/>
@@ -2965,7 +2965,7 @@
                   <a:schemeClr val="tx1"/>
                 </a:solidFill>
               </a:rPr>
-              <a:t>Interest and Principal</a:t>
+              <a:t>Earnings and Principal</a:t>
             </a:r>
             <a:pPr indent="0" marL="0">
               <a:buNone/>
@@ -2976,7 +2976,7 @@
                   <a:schemeClr val="tx1"/>
                 </a:solidFill>
               </a:rPr>
-              <a:t> instead of Interest Only.</a:t>
+              <a:t> instead of Earnings Only.</a:t>
             </a:r>
             <a:endParaRPr lang="en-US" sz="1400" dirty="0"/>
           </a:p>
@@ -3120,7 +3120,7 @@
                   <a:schemeClr val="tx1"/>
                 </a:solidFill>
               </a:rPr>
-              <a:t>Interest every 3 months, 4 payouts a year, your full amount back at the end of the term</a:t>
+              <a:t>Earnings every 3 months, 4 payouts a year, your full amount back at the end of the term</a:t>
             </a:r>
             <a:endParaRPr lang="en-US" sz="1400" dirty="0"/>
           </a:p>
@@ -3643,7 +3643,7 @@
                             <a:srgbClr val="16285A"/>
                           </a:solidFill>
                         </a:rPr>
-                        <a:t>Interest</a:t>
+                        <a:t>Earnings</a:t>
                       </a:r>
                       <a:endParaRPr lang="en-US" sz="1200" dirty="0"/>
                     </a:p>
@@ -3765,7 +3765,7 @@
                             <a:srgbClr val="16285A"/>
                           </a:solidFill>
                         </a:rPr>
-                        <a:t>Interest</a:t>
+                        <a:t>Earnings</a:t>
                       </a:r>
                       <a:endParaRPr lang="en-US" sz="1200" dirty="0"/>
                     </a:p>
@@ -4878,7 +4878,7 @@
                   <a:schemeClr val="tx1"/>
                 </a:solidFill>
               </a:rPr>
-              <a:t>$16,000 in interest</a:t>
+              <a:t>$16,000 in earnings</a:t>
             </a:r>
             <a:pPr indent="0" marL="0">
               <a:buNone/>
@@ -4925,7 +4925,7 @@
                   <a:schemeClr val="accent4"/>
                 </a:solidFill>
               </a:rPr>
-              <a:t>Interest Only payouts shown. Illustrative figures; see the disclaimer at the end.</a:t>
+              <a:t>Earnings Only payouts shown. Illustrative figures; see the disclaimer at the end.</a:t>
             </a:r>
             <a:endParaRPr lang="en-US" sz="1000" dirty="0"/>
           </a:p>
@@ -5069,7 +5069,7 @@
                   <a:schemeClr val="tx1"/>
                 </a:solidFill>
               </a:rPr>
-              <a:t>Interest every 6 months, 2 payouts a year, your full amount back at the end of the term</a:t>
+              <a:t>Earnings every 6 months, 2 payouts a year, your full amount back at the end of the term</a:t>
             </a:r>
             <a:endParaRPr lang="en-US" sz="1400" dirty="0"/>
           </a:p>
@@ -5592,7 +5592,7 @@
                             <a:srgbClr val="16285A"/>
                           </a:solidFill>
                         </a:rPr>
-                        <a:t>Interest</a:t>
+                        <a:t>Earnings</a:t>
                       </a:r>
                       <a:endParaRPr lang="en-US" sz="1200" dirty="0"/>
                     </a:p>
@@ -5714,7 +5714,7 @@
                             <a:srgbClr val="16285A"/>
                           </a:solidFill>
                         </a:rPr>
-                        <a:t>Interest</a:t>
+                        <a:t>Earnings</a:t>
                       </a:r>
                       <a:endParaRPr lang="en-US" sz="1200" dirty="0"/>
                     </a:p>
@@ -6827,7 +6827,7 @@
                   <a:schemeClr val="tx1"/>
                 </a:solidFill>
               </a:rPr>
-              <a:t>$18,000 in interest</a:t>
+              <a:t>$18,000 in earnings</a:t>
             </a:r>
             <a:pPr indent="0" marL="0">
               <a:buNone/>
@@ -6874,7 +6874,7 @@
                   <a:schemeClr val="accent4"/>
                 </a:solidFill>
               </a:rPr>
-              <a:t>Interest Only payouts shown. Illustrative figures; see the disclaimer at the end.</a:t>
+              <a:t>Earnings Only payouts shown. Illustrative figures; see the disclaimer at the end.</a:t>
             </a:r>
             <a:endParaRPr lang="en-US" sz="1000" dirty="0"/>
           </a:p>
@@ -7018,7 +7018,7 @@
                   <a:schemeClr val="tx1"/>
                 </a:solidFill>
               </a:rPr>
-              <a:t>Interest once a year, 1 payout a year, your full amount back at the end of the term</a:t>
+              <a:t>Earnings once a year, 1 payout a year, your full amount back at the end of the term</a:t>
             </a:r>
             <a:endParaRPr lang="en-US" sz="1400" dirty="0"/>
           </a:p>
@@ -7541,7 +7541,7 @@
                             <a:srgbClr val="16285A"/>
                           </a:solidFill>
                         </a:rPr>
-                        <a:t>Interest</a:t>
+                        <a:t>Earnings</a:t>
                       </a:r>
                       <a:endParaRPr lang="en-US" sz="1200" dirty="0"/>
                     </a:p>
@@ -7663,7 +7663,7 @@
                             <a:srgbClr val="16285A"/>
                           </a:solidFill>
                         </a:rPr>
-                        <a:t>Interest</a:t>
+                        <a:t>Earnings</a:t>
                       </a:r>
                       <a:endParaRPr lang="en-US" sz="1200" dirty="0"/>
                     </a:p>
@@ -8776,7 +8776,7 @@
                   <a:schemeClr val="tx1"/>
                 </a:solidFill>
               </a:rPr>
-              <a:t>$20,000 in interest</a:t>
+              <a:t>$20,000 in earnings</a:t>
             </a:r>
             <a:pPr indent="0" marL="0">
               <a:buNone/>
@@ -8823,7 +8823,7 @@
                   <a:schemeClr val="accent4"/>
                 </a:solidFill>
               </a:rPr>
-              <a:t>Interest Only payouts shown. Illustrative figures; see the disclaimer at the end.</a:t>
+              <a:t>Earnings Only payouts shown. Illustrative figures; see the disclaimer at the end.</a:t>
             </a:r>
             <a:endParaRPr lang="en-US" sz="1000" dirty="0"/>
           </a:p>
@@ -9171,7 +9171,7 @@
                   <a:schemeClr val="bg2"/>
                 </a:solidFill>
               </a:rPr>
-              <a:t>Disclaimer: This calculator provides illustrative estimates based on the selected assumptions. Interest is assumed to start on the next business day after the planned investment date, counting Monday to Friday as business days; public holidays are not taken into account. Actual returns, payment timing, taxes, fees, and principal repayment may differ. This calculator is not a guarantee of investment performance or a substitute for professional financial advice.</a:t>
+              <a:t>Disclaimer: This calculator provides illustrative estimates based on the selected assumptions. Earnings are assumed to start on the next business day after the planned investment date, counting Monday to Friday as business days; public holidays are not taken into account. Actual returns, payment timing, taxes, fees, and principal repayment may differ. This calculator is not a guarantee of investment performance or a substitute for professional financial advice.</a:t>
             </a:r>
             <a:endParaRPr lang="en-US" sz="1000" dirty="0"/>
           </a:p>

</xml_diff>